<commit_message>
Polish pitch deck: fix kicker number wrapping
</commit_message>
<xml_diff>
--- a/presentation/IEPrep_Pitch_Deck.pptx
+++ b/presentation/IEPrep_Pitch_Deck.pptx
@@ -2895,14 +2895,16 @@
           <a:ln/>
         </p:spPr>
         <p:txBody>
-          <a:bodyPr wrap="square" rtlCol="0" anchor="ctr"/>
+          <a:bodyPr wrap="square" lIns="0" tIns="0" rIns="0" bIns="0" rtlCol="0" anchor="ctr">
+            <a:spAutoFit/>
+          </a:bodyPr>
           <a:lstStyle/>
           <a:p>
             <a:pPr algn="ctr" indent="0" marL="0">
               <a:buNone/>
             </a:pPr>
             <a:r>
-              <a:rPr lang="en-US" sz="2000" b="1" dirty="0">
+              <a:rPr lang="en-US" sz="1800" b="1" dirty="0">
                 <a:solidFill>
                   <a:srgbClr val="FFFFFF"/>
                 </a:solidFill>
@@ -2912,7 +2914,7 @@
               </a:rPr>
               <a:t>01</a:t>
             </a:r>
-            <a:endParaRPr lang="en-US" sz="2000" dirty="0"/>
+            <a:endParaRPr lang="en-US" sz="1800" dirty="0"/>
           </a:p>
         </p:txBody>
       </p:sp>
@@ -3878,14 +3880,16 @@
           <a:ln/>
         </p:spPr>
         <p:txBody>
-          <a:bodyPr wrap="square" rtlCol="0" anchor="ctr"/>
+          <a:bodyPr wrap="square" lIns="0" tIns="0" rIns="0" bIns="0" rtlCol="0" anchor="ctr">
+            <a:spAutoFit/>
+          </a:bodyPr>
           <a:lstStyle/>
           <a:p>
             <a:pPr algn="ctr" indent="0" marL="0">
               <a:buNone/>
             </a:pPr>
             <a:r>
-              <a:rPr lang="en-US" sz="2000" b="1" dirty="0">
+              <a:rPr lang="en-US" sz="1800" b="1" dirty="0">
                 <a:solidFill>
                   <a:srgbClr val="FFFFFF"/>
                 </a:solidFill>
@@ -3895,7 +3899,7 @@
               </a:rPr>
               <a:t>02</a:t>
             </a:r>
-            <a:endParaRPr lang="en-US" sz="2000" dirty="0"/>
+            <a:endParaRPr lang="en-US" sz="1800" dirty="0"/>
           </a:p>
         </p:txBody>
       </p:sp>
@@ -5382,14 +5386,16 @@
           <a:ln/>
         </p:spPr>
         <p:txBody>
-          <a:bodyPr wrap="square" rtlCol="0" anchor="ctr"/>
+          <a:bodyPr wrap="square" lIns="0" tIns="0" rIns="0" bIns="0" rtlCol="0" anchor="ctr">
+            <a:spAutoFit/>
+          </a:bodyPr>
           <a:lstStyle/>
           <a:p>
             <a:pPr algn="ctr" indent="0" marL="0">
               <a:buNone/>
             </a:pPr>
             <a:r>
-              <a:rPr lang="en-US" sz="2000" b="1" dirty="0">
+              <a:rPr lang="en-US" sz="1800" b="1" dirty="0">
                 <a:solidFill>
                   <a:srgbClr val="FFFFFF"/>
                 </a:solidFill>
@@ -5399,7 +5405,7 @@
               </a:rPr>
               <a:t>04</a:t>
             </a:r>
-            <a:endParaRPr lang="en-US" sz="2000" dirty="0"/>
+            <a:endParaRPr lang="en-US" sz="1800" dirty="0"/>
           </a:p>
         </p:txBody>
       </p:sp>
@@ -6372,14 +6378,16 @@
           <a:ln/>
         </p:spPr>
         <p:txBody>
-          <a:bodyPr wrap="square" rtlCol="0" anchor="ctr"/>
+          <a:bodyPr wrap="square" lIns="0" tIns="0" rIns="0" bIns="0" rtlCol="0" anchor="ctr">
+            <a:spAutoFit/>
+          </a:bodyPr>
           <a:lstStyle/>
           <a:p>
             <a:pPr algn="ctr" indent="0" marL="0">
               <a:buNone/>
             </a:pPr>
             <a:r>
-              <a:rPr lang="en-US" sz="2000" b="1" dirty="0">
+              <a:rPr lang="en-US" sz="1800" b="1" dirty="0">
                 <a:solidFill>
                   <a:srgbClr val="FFFFFF"/>
                 </a:solidFill>
@@ -6389,7 +6397,7 @@
               </a:rPr>
               <a:t>05</a:t>
             </a:r>
-            <a:endParaRPr lang="en-US" sz="2000" dirty="0"/>
+            <a:endParaRPr lang="en-US" sz="1800" dirty="0"/>
           </a:p>
         </p:txBody>
       </p:sp>
@@ -7456,14 +7464,16 @@
           <a:ln/>
         </p:spPr>
         <p:txBody>
-          <a:bodyPr wrap="square" rtlCol="0" anchor="ctr"/>
+          <a:bodyPr wrap="square" lIns="0" tIns="0" rIns="0" bIns="0" rtlCol="0" anchor="ctr">
+            <a:spAutoFit/>
+          </a:bodyPr>
           <a:lstStyle/>
           <a:p>
             <a:pPr algn="ctr" indent="0" marL="0">
               <a:buNone/>
             </a:pPr>
             <a:r>
-              <a:rPr lang="en-US" sz="2000" b="1" dirty="0">
+              <a:rPr lang="en-US" sz="1800" b="1" dirty="0">
                 <a:solidFill>
                   <a:srgbClr val="FFFFFF"/>
                 </a:solidFill>
@@ -7473,7 +7483,7 @@
               </a:rPr>
               <a:t>06</a:t>
             </a:r>
-            <a:endParaRPr lang="en-US" sz="2000" dirty="0"/>
+            <a:endParaRPr lang="en-US" sz="1800" dirty="0"/>
           </a:p>
         </p:txBody>
       </p:sp>
@@ -8196,14 +8206,16 @@
           <a:ln/>
         </p:spPr>
         <p:txBody>
-          <a:bodyPr wrap="square" rtlCol="0" anchor="ctr"/>
+          <a:bodyPr wrap="square" lIns="0" tIns="0" rIns="0" bIns="0" rtlCol="0" anchor="ctr">
+            <a:spAutoFit/>
+          </a:bodyPr>
           <a:lstStyle/>
           <a:p>
             <a:pPr algn="ctr" indent="0" marL="0">
               <a:buNone/>
             </a:pPr>
             <a:r>
-              <a:rPr lang="en-US" sz="2000" b="1" dirty="0">
+              <a:rPr lang="en-US" sz="1800" b="1" dirty="0">
                 <a:solidFill>
                   <a:srgbClr val="FFFFFF"/>
                 </a:solidFill>
@@ -8213,7 +8225,7 @@
               </a:rPr>
               <a:t>07</a:t>
             </a:r>
-            <a:endParaRPr lang="en-US" sz="2000" dirty="0"/>
+            <a:endParaRPr lang="en-US" sz="1800" dirty="0"/>
           </a:p>
         </p:txBody>
       </p:sp>

</xml_diff>